<commit_message>
feat(render): industry context section in outputs (plan step 20) (#1)
Step 20 implemented by the coder agent and finished after review and a
visual check: every AI-chosen phrase ("Supported out of the box" etc.)
now appears with its verbatim quote in every format, slides included,
on a dedicated Industry context layout; citations are never rewritten by
the anonymiser (a client's own site as source is dropped instead); the
audit row records which research fed an output; research text is shown
never to reach case records. Completes Phase 4.

Co-Authored-By: Claude Opus 5.5 <noreply@anthropic.com>
Claude-Session: https://claude.ai/code/session_01MPRoCfbJuTDz6tit2f4eFM
</commit_message>
<xml_diff>
--- a/brand/master.pptx
+++ b/brand/master.pptx
@@ -2226,7 +2226,7 @@
 
 <file path=ppt/slideLayouts/slideLayout7.xml><?xml version="1.0" encoding="utf-8"?>
 <p:sldLayout xmlns:a="http://schemas.openxmlformats.org/drawingml/2006/main" xmlns:r="http://schemas.openxmlformats.org/officeDocument/2006/relationships" xmlns:p="http://schemas.openxmlformats.org/presentationml/2006/main" type="blank" preserve="1">
-  <p:cSld name="Blank">
+  <p:cSld name="Industry context">
     <p:spTree>
       <p:nvGrpSpPr>
         <p:cNvPr id="1" name=""/>
@@ -2243,66 +2243,129 @@
       </p:grpSpPr>
       <p:sp>
         <p:nvSpPr>
-          <p:cNvPr id="2" name="Date Placeholder 1"/>
-          <p:cNvSpPr>
-            <a:spLocks noGrp="1"/>
-          </p:cNvSpPr>
-          <p:nvPr>
-            <p:ph type="dt" sz="half" idx="10"/>
-          </p:nvPr>
-        </p:nvSpPr>
-        <p:spPr/>
-        <p:txBody>
-          <a:bodyPr/>
-          <a:lstStyle/>
-          <a:p>
-            <a:fld id="{5BCAD085-E8A6-8845-BD4E-CB4CCA059FC4}" type="datetimeFigureOut">
-              <a:rPr lang="en-US" smtClean="0"/>
-              <a:t>1/27/13</a:t>
-            </a:fld>
-            <a:endParaRPr lang="en-US"/>
-          </a:p>
-        </p:txBody>
-      </p:sp>
-      <p:sp>
-        <p:nvSpPr>
-          <p:cNvPr id="3" name="Footer Placeholder 2"/>
-          <p:cNvSpPr>
-            <a:spLocks noGrp="1"/>
-          </p:cNvSpPr>
-          <p:nvPr>
-            <p:ph type="ftr" sz="quarter" idx="11"/>
-          </p:nvPr>
-        </p:nvSpPr>
-        <p:spPr/>
-        <p:txBody>
-          <a:bodyPr/>
-          <a:lstStyle/>
-          <a:p>
-            <a:endParaRPr lang="en-US"/>
-          </a:p>
-        </p:txBody>
-      </p:sp>
-      <p:sp>
-        <p:nvSpPr>
-          <p:cNvPr id="4" name="Slide Number Placeholder 3"/>
-          <p:cNvSpPr>
-            <a:spLocks noGrp="1"/>
-          </p:cNvSpPr>
-          <p:nvPr>
-            <p:ph type="sldNum" sz="quarter" idx="12"/>
-          </p:nvPr>
-        </p:nvSpPr>
-        <p:spPr/>
-        <p:txBody>
-          <a:bodyPr/>
-          <a:lstStyle/>
-          <a:p>
-            <a:fld id="{C1FF6DA9-008F-8B48-92A6-B652298478BF}" type="slidenum">
-              <a:rPr lang="en-US" smtClean="0"/>
-              <a:t>‹#›</a:t>
-            </a:fld>
-            <a:endParaRPr lang="en-US"/>
+          <p:cNvPr id="100" name="Title"/>
+          <p:cNvSpPr/>
+          <p:nvPr>
+            <p:ph type="title"/>
+          </p:nvPr>
+        </p:nvSpPr>
+        <p:spPr>
+          <a:xfrm>
+            <a:off x="457200" y="274320"/>
+            <a:ext cx="8229600" cy="731520"/>
+          </a:xfrm>
+        </p:spPr>
+        <p:txBody>
+          <a:bodyPr wrap="square">
+            <a:normAutofit/>
+          </a:bodyPr>
+          <a:lstStyle>
+            <a:lvl1pPr marL="0" indent="0" algn="l">
+              <a:buNone/>
+              <a:defRPr sz="2400" b="1" i="0"/>
+            </a:lvl1pPr>
+          </a:lstStyle>
+          <a:p>
+            <a:r>
+              <a:rPr lang="en-US"/>
+              <a:t>Title</a:t>
+            </a:r>
+          </a:p>
+        </p:txBody>
+      </p:sp>
+      <p:sp>
+        <p:nvSpPr>
+          <p:cNvPr id="101" name="Summary"/>
+          <p:cNvSpPr/>
+          <p:nvPr>
+            <p:ph type="body" sz="quarter" idx="21"/>
+          </p:nvPr>
+        </p:nvSpPr>
+        <p:spPr>
+          <a:xfrm>
+            <a:off x="457200" y="1005840"/>
+            <a:ext cx="8229600" cy="457200"/>
+          </a:xfrm>
+        </p:spPr>
+        <p:txBody>
+          <a:bodyPr wrap="square">
+            <a:normAutofit/>
+          </a:bodyPr>
+          <a:lstStyle>
+            <a:lvl1pPr marL="0" indent="0" algn="l">
+              <a:buNone/>
+              <a:defRPr sz="1200" b="0" i="1">
+                <a:solidFill>
+                  <a:srgbClr val="595959"/>
+                </a:solidFill>
+              </a:defRPr>
+            </a:lvl1pPr>
+          </a:lstStyle>
+          <a:p>
+            <a:r>
+              <a:rPr lang="en-US"/>
+              <a:t>Summary</a:t>
+            </a:r>
+          </a:p>
+        </p:txBody>
+      </p:sp>
+      <p:sp>
+        <p:nvSpPr>
+          <p:cNvPr id="102" name="Statements"/>
+          <p:cNvSpPr/>
+          <p:nvPr>
+            <p:ph type="body" sz="quarter" idx="22"/>
+          </p:nvPr>
+        </p:nvSpPr>
+        <p:spPr>
+          <a:xfrm>
+            <a:off x="457200" y="1645920"/>
+            <a:ext cx="8229600" cy="4572000"/>
+          </a:xfrm>
+        </p:spPr>
+        <p:txBody>
+          <a:bodyPr wrap="square">
+            <a:normAutofit/>
+          </a:bodyPr>
+          <a:lstStyle>
+            <a:lvl1pPr marL="228600" indent="-228600" algn="l">
+              <a:defRPr sz="1100" b="0" i="0"/>
+            </a:lvl1pPr>
+          </a:lstStyle>
+          <a:p>
+            <a:r>
+              <a:rPr lang="en-US"/>
+              <a:t>Statements</a:t>
+            </a:r>
+          </a:p>
+        </p:txBody>
+      </p:sp>
+      <p:sp>
+        <p:nvSpPr>
+          <p:cNvPr id="200" name="Draft notice"/>
+          <p:cNvSpPr/>
+          <p:nvPr/>
+        </p:nvSpPr>
+        <p:spPr>
+          <a:xfrm>
+            <a:off x="457200" y="6355080"/>
+            <a:ext cx="8229600" cy="320040"/>
+          </a:xfrm>
+        </p:spPr>
+        <p:txBody>
+          <a:bodyPr wrap="square">
+            <a:normAutofit/>
+          </a:bodyPr>
+          <a:lstStyle/>
+          <a:p>
+            <a:r>
+              <a:rPr lang="en-US" sz="1200" b="1" i="0">
+                <a:solidFill>
+                  <a:srgbClr val="C00000"/>
+                </a:solidFill>
+              </a:rPr>
+              <a:t>DRAFT TEMPLATE – replace with the marketing master</a:t>
+            </a:r>
           </a:p>
         </p:txBody>
       </p:sp>

</xml_diff>

<commit_message>
feat(render): one PowerPoint slide per diagram on a Diagram layout (plan #200 step 12) (#200)
Co-Authored-By: Claude Sonnet 5.5 <noreply@anthropic.com>
Co-Authored-By: Claude Opus 5.5 <noreply@anthropic.com>
Claude-Session: https://claude.ai/code/session_01MPRoCfbJuTDz6tit2f4eFM
</commit_message>
<xml_diff>
--- a/brand/master.pptx
+++ b/brand/master.pptx
@@ -2384,7 +2384,7 @@
 
 <file path=ppt/slideLayouts/slideLayout8.xml><?xml version="1.0" encoding="utf-8"?>
 <p:sldLayout xmlns:a="http://schemas.openxmlformats.org/drawingml/2006/main" xmlns:r="http://schemas.openxmlformats.org/officeDocument/2006/relationships" xmlns:p="http://schemas.openxmlformats.org/presentationml/2006/main" type="objTx" preserve="1">
-  <p:cSld name="Content with Caption">
+  <p:cSld name="Diagram">
     <p:spTree>
       <p:nvGrpSpPr>
         <p:cNvPr id="1" name=""/>
@@ -2401,248 +2401,130 @@
       </p:grpSpPr>
       <p:sp>
         <p:nvSpPr>
-          <p:cNvPr id="2" name="Title 1"/>
-          <p:cNvSpPr>
-            <a:spLocks noGrp="1"/>
-          </p:cNvSpPr>
+          <p:cNvPr id="100" name="Title"/>
+          <p:cNvSpPr/>
           <p:nvPr>
             <p:ph type="title"/>
           </p:nvPr>
         </p:nvSpPr>
         <p:spPr>
           <a:xfrm>
-            <a:off x="457200" y="273050"/>
-            <a:ext cx="3008313" cy="1162050"/>
-          </a:xfrm>
-        </p:spPr>
-        <p:txBody>
-          <a:bodyPr anchor="b"/>
+            <a:off x="457200" y="274320"/>
+            <a:ext cx="8229600" cy="731520"/>
+          </a:xfrm>
+        </p:spPr>
+        <p:txBody>
+          <a:bodyPr wrap="square">
+            <a:normAutofit/>
+          </a:bodyPr>
           <a:lstStyle>
-            <a:lvl1pPr algn="l">
-              <a:defRPr sz="2000" b="1"/>
+            <a:lvl1pPr marL="0" indent="0" algn="l">
+              <a:buNone/>
+              <a:defRPr sz="2400" b="1" i="0"/>
             </a:lvl1pPr>
           </a:lstStyle>
           <a:p>
             <a:r>
-              <a:rPr lang="en-US" smtClean="0"/>
-              <a:t>Click to edit Master title style</a:t>
-            </a:r>
-            <a:endParaRPr lang="en-US"/>
-          </a:p>
-        </p:txBody>
-      </p:sp>
-      <p:sp>
-        <p:nvSpPr>
-          <p:cNvPr id="3" name="Content Placeholder 2"/>
-          <p:cNvSpPr>
-            <a:spLocks noGrp="1"/>
-          </p:cNvSpPr>
-          <p:nvPr>
-            <p:ph idx="1"/>
-          </p:nvPr>
-        </p:nvSpPr>
-        <p:spPr>
-          <a:xfrm>
-            <a:off x="3575050" y="273050"/>
-            <a:ext cx="5111750" cy="5853113"/>
-          </a:xfrm>
-        </p:spPr>
-        <p:txBody>
-          <a:bodyPr/>
+              <a:rPr lang="en-US"/>
+              <a:t>Title</a:t>
+            </a:r>
+          </a:p>
+        </p:txBody>
+      </p:sp>
+      <p:sp>
+        <p:nvSpPr>
+          <p:cNvPr id="101" name="Picture"/>
+          <p:cNvSpPr/>
+          <p:nvPr>
+            <p:ph type="body" sz="quarter" idx="21"/>
+          </p:nvPr>
+        </p:nvSpPr>
+        <p:spPr>
+          <a:xfrm>
+            <a:off x="457200" y="1097280"/>
+            <a:ext cx="8229600" cy="4572000"/>
+          </a:xfrm>
+        </p:spPr>
+        <p:txBody>
+          <a:bodyPr wrap="square">
+            <a:normAutofit/>
+          </a:bodyPr>
           <a:lstStyle>
-            <a:lvl1pPr>
-              <a:defRPr sz="3200"/>
+            <a:lvl1pPr marL="0" indent="0" algn="l">
+              <a:buNone/>
+              <a:defRPr sz="1100" b="0" i="0"/>
             </a:lvl1pPr>
-            <a:lvl2pPr>
-              <a:defRPr sz="2800"/>
-            </a:lvl2pPr>
-            <a:lvl3pPr>
-              <a:defRPr sz="2400"/>
-            </a:lvl3pPr>
-            <a:lvl4pPr>
-              <a:defRPr sz="2000"/>
-            </a:lvl4pPr>
-            <a:lvl5pPr>
-              <a:defRPr sz="2000"/>
-            </a:lvl5pPr>
-            <a:lvl6pPr>
-              <a:defRPr sz="2000"/>
-            </a:lvl6pPr>
-            <a:lvl7pPr>
-              <a:defRPr sz="2000"/>
-            </a:lvl7pPr>
-            <a:lvl8pPr>
-              <a:defRPr sz="2000"/>
-            </a:lvl8pPr>
-            <a:lvl9pPr>
-              <a:defRPr sz="2000"/>
-            </a:lvl9pPr>
           </a:lstStyle>
           <a:p>
-            <a:pPr lvl="0"/>
-            <a:r>
-              <a:rPr lang="en-US" smtClean="0"/>
-              <a:t>Click to edit Master text styles</a:t>
-            </a:r>
-          </a:p>
-          <a:p>
-            <a:pPr lvl="1"/>
-            <a:r>
-              <a:rPr lang="en-US" smtClean="0"/>
-              <a:t>Second level</a:t>
-            </a:r>
-          </a:p>
-          <a:p>
-            <a:pPr lvl="2"/>
-            <a:r>
-              <a:rPr lang="en-US" smtClean="0"/>
-              <a:t>Third level</a:t>
-            </a:r>
-          </a:p>
-          <a:p>
-            <a:pPr lvl="3"/>
-            <a:r>
-              <a:rPr lang="en-US" smtClean="0"/>
-              <a:t>Fourth level</a:t>
-            </a:r>
-          </a:p>
-          <a:p>
-            <a:pPr lvl="4"/>
-            <a:r>
-              <a:rPr lang="en-US" smtClean="0"/>
-              <a:t>Fifth level</a:t>
-            </a:r>
-            <a:endParaRPr lang="en-US"/>
-          </a:p>
-        </p:txBody>
-      </p:sp>
-      <p:sp>
-        <p:nvSpPr>
-          <p:cNvPr id="4" name="Text Placeholder 3"/>
-          <p:cNvSpPr>
-            <a:spLocks noGrp="1"/>
-          </p:cNvSpPr>
-          <p:nvPr>
-            <p:ph type="body" sz="half" idx="2"/>
-          </p:nvPr>
-        </p:nvSpPr>
-        <p:spPr>
-          <a:xfrm>
-            <a:off x="457200" y="1435100"/>
-            <a:ext cx="3008313" cy="4691063"/>
-          </a:xfrm>
-        </p:spPr>
-        <p:txBody>
-          <a:bodyPr/>
+            <a:r>
+              <a:rPr lang="en-US"/>
+              <a:t>Picture</a:t>
+            </a:r>
+          </a:p>
+        </p:txBody>
+      </p:sp>
+      <p:sp>
+        <p:nvSpPr>
+          <p:cNvPr id="102" name="Caption"/>
+          <p:cNvSpPr/>
+          <p:nvPr>
+            <p:ph type="body" sz="quarter" idx="22"/>
+          </p:nvPr>
+        </p:nvSpPr>
+        <p:spPr>
+          <a:xfrm>
+            <a:off x="457200" y="5760720"/>
+            <a:ext cx="8229600" cy="457200"/>
+          </a:xfrm>
+        </p:spPr>
+        <p:txBody>
+          <a:bodyPr wrap="square">
+            <a:normAutofit/>
+          </a:bodyPr>
           <a:lstStyle>
-            <a:lvl1pPr marL="0" indent="0">
-              <a:buNone/>
-              <a:defRPr sz="1400"/>
+            <a:lvl1pPr marL="0" indent="0" algn="l">
+              <a:buNone/>
+              <a:defRPr sz="1200" b="0" i="1">
+                <a:solidFill>
+                  <a:srgbClr val="595959"/>
+                </a:solidFill>
+              </a:defRPr>
             </a:lvl1pPr>
-            <a:lvl2pPr marL="457200" indent="0">
-              <a:buNone/>
-              <a:defRPr sz="1200"/>
-            </a:lvl2pPr>
-            <a:lvl3pPr marL="914400" indent="0">
-              <a:buNone/>
-              <a:defRPr sz="1000"/>
-            </a:lvl3pPr>
-            <a:lvl4pPr marL="1371600" indent="0">
-              <a:buNone/>
-              <a:defRPr sz="900"/>
-            </a:lvl4pPr>
-            <a:lvl5pPr marL="1828800" indent="0">
-              <a:buNone/>
-              <a:defRPr sz="900"/>
-            </a:lvl5pPr>
-            <a:lvl6pPr marL="2286000" indent="0">
-              <a:buNone/>
-              <a:defRPr sz="900"/>
-            </a:lvl6pPr>
-            <a:lvl7pPr marL="2743200" indent="0">
-              <a:buNone/>
-              <a:defRPr sz="900"/>
-            </a:lvl7pPr>
-            <a:lvl8pPr marL="3200400" indent="0">
-              <a:buNone/>
-              <a:defRPr sz="900"/>
-            </a:lvl8pPr>
-            <a:lvl9pPr marL="3657600" indent="0">
-              <a:buNone/>
-              <a:defRPr sz="900"/>
-            </a:lvl9pPr>
           </a:lstStyle>
           <a:p>
-            <a:pPr lvl="0"/>
-            <a:r>
-              <a:rPr lang="en-US" smtClean="0"/>
-              <a:t>Click to edit Master text styles</a:t>
-            </a:r>
-          </a:p>
-        </p:txBody>
-      </p:sp>
-      <p:sp>
-        <p:nvSpPr>
-          <p:cNvPr id="5" name="Date Placeholder 4"/>
-          <p:cNvSpPr>
-            <a:spLocks noGrp="1"/>
-          </p:cNvSpPr>
-          <p:nvPr>
-            <p:ph type="dt" sz="half" idx="10"/>
-          </p:nvPr>
-        </p:nvSpPr>
-        <p:spPr/>
-        <p:txBody>
-          <a:bodyPr/>
-          <a:lstStyle/>
-          <a:p>
-            <a:fld id="{5BCAD085-E8A6-8845-BD4E-CB4CCA059FC4}" type="datetimeFigureOut">
-              <a:rPr lang="en-US" smtClean="0"/>
-              <a:t>1/27/13</a:t>
-            </a:fld>
-            <a:endParaRPr lang="en-US"/>
-          </a:p>
-        </p:txBody>
-      </p:sp>
-      <p:sp>
-        <p:nvSpPr>
-          <p:cNvPr id="6" name="Footer Placeholder 5"/>
-          <p:cNvSpPr>
-            <a:spLocks noGrp="1"/>
-          </p:cNvSpPr>
-          <p:nvPr>
-            <p:ph type="ftr" sz="quarter" idx="11"/>
-          </p:nvPr>
-        </p:nvSpPr>
-        <p:spPr/>
-        <p:txBody>
-          <a:bodyPr/>
-          <a:lstStyle/>
-          <a:p>
-            <a:endParaRPr lang="en-US"/>
-          </a:p>
-        </p:txBody>
-      </p:sp>
-      <p:sp>
-        <p:nvSpPr>
-          <p:cNvPr id="7" name="Slide Number Placeholder 6"/>
-          <p:cNvSpPr>
-            <a:spLocks noGrp="1"/>
-          </p:cNvSpPr>
-          <p:nvPr>
-            <p:ph type="sldNum" sz="quarter" idx="12"/>
-          </p:nvPr>
-        </p:nvSpPr>
-        <p:spPr/>
-        <p:txBody>
-          <a:bodyPr/>
-          <a:lstStyle/>
-          <a:p>
-            <a:fld id="{C1FF6DA9-008F-8B48-92A6-B652298478BF}" type="slidenum">
-              <a:rPr lang="en-US" smtClean="0"/>
-              <a:t>‹#›</a:t>
-            </a:fld>
-            <a:endParaRPr lang="en-US"/>
+            <a:r>
+              <a:rPr lang="en-US"/>
+              <a:t>Caption</a:t>
+            </a:r>
+          </a:p>
+        </p:txBody>
+      </p:sp>
+      <p:sp>
+        <p:nvSpPr>
+          <p:cNvPr id="200" name="Draft notice"/>
+          <p:cNvSpPr/>
+          <p:nvPr/>
+        </p:nvSpPr>
+        <p:spPr>
+          <a:xfrm>
+            <a:off x="457200" y="6355080"/>
+            <a:ext cx="8229600" cy="320040"/>
+          </a:xfrm>
+        </p:spPr>
+        <p:txBody>
+          <a:bodyPr wrap="square">
+            <a:normAutofit/>
+          </a:bodyPr>
+          <a:lstStyle/>
+          <a:p>
+            <a:r>
+              <a:rPr lang="en-US" sz="1200" b="1" i="0">
+                <a:solidFill>
+                  <a:srgbClr val="C00000"/>
+                </a:solidFill>
+              </a:rPr>
+              <a:t>DRAFT TEMPLATE – replace with the marketing master</a:t>
+            </a:r>
           </a:p>
         </p:txBody>
       </p:sp>

</xml_diff>

<commit_message>
fix(brand): bullets in Aptos, not the master's Arial, so PDFs embed only Aptos (plan #282 step E) (#282)
Co-Authored-By: Claude Opus 5.5 <noreply@anthropic.com>
Claude-Session: https://claude.ai/code/session_01MPRoCfbJuTDz6tit2f4eFM
</commit_message>
<xml_diff>
--- a/brand/master.pptx
+++ b/brand/master.pptx
@@ -1114,6 +1114,8 @@
           </a:bodyPr>
           <a:lstStyle>
             <a:lvl1pPr marL="228600" indent="-228600" algn="l">
+              <a:buFont typeface="Aptos"/>
+              <a:buChar char="•"/>
               <a:defRPr sz="1100" b="0">
                 <a:solidFill>
                   <a:srgbClr val="000000"/>
@@ -1422,6 +1424,8 @@
           </a:bodyPr>
           <a:lstStyle>
             <a:lvl1pPr marL="228600" indent="-228600" algn="l">
+              <a:buFont typeface="Aptos"/>
+              <a:buChar char="•"/>
               <a:defRPr sz="1100" b="0">
                 <a:solidFill>
                   <a:srgbClr val="000000"/>

</xml_diff>

<commit_message>
fix(brand): every Arial in the template becomes Aptos; PDFs embed only Aptos, with a test (plan #282 step E) (#282)
Co-Authored-By: Claude Opus 5.5 <noreply@anthropic.com>
Claude-Session: https://claude.ai/code/session_01MPRoCfbJuTDz6tit2f4eFM
</commit_message>
<xml_diff>
--- a/brand/master.pptx
+++ b/brand/master.pptx
@@ -1875,8 +1875,8 @@
                 <a:solidFill>
                   <a:srgbClr val="FFFFFF"/>
                 </a:solidFill>
-                <a:latin typeface="Arial" panose="020B0604020202020204" pitchFamily="34" charset="0"/>
-                <a:cs typeface="Arial" panose="020B0604020202020204" pitchFamily="34" charset="0"/>
+                <a:latin typeface="Aptos"/>
+                <a:cs typeface="Aptos"/>
               </a:rPr>
               <a:t>© Copyright 202</a:t>
             </a:r>
@@ -1885,8 +1885,8 @@
                 <a:solidFill>
                   <a:srgbClr val="FFFFFF"/>
                 </a:solidFill>
-                <a:latin typeface="Arial" panose="020B0604020202020204" pitchFamily="34" charset="0"/>
-                <a:cs typeface="Arial" panose="020B0604020202020204" pitchFamily="34" charset="0"/>
+                <a:latin typeface="Aptos"/>
+                <a:cs typeface="Aptos"/>
               </a:rPr>
               <a:t>6</a:t>
             </a:r>
@@ -1895,8 +1895,8 @@
                 <a:solidFill>
                   <a:srgbClr val="FFFFFF"/>
                 </a:solidFill>
-                <a:latin typeface="Arial" panose="020B0604020202020204" pitchFamily="34" charset="0"/>
-                <a:cs typeface="Arial" panose="020B0604020202020204" pitchFamily="34" charset="0"/>
+                <a:latin typeface="Aptos"/>
+                <a:cs typeface="Aptos"/>
               </a:rPr>
               <a:t>. </a:t>
             </a:r>
@@ -1905,8 +1905,8 @@
                 <a:solidFill>
                   <a:srgbClr val="FFFFFF"/>
                 </a:solidFill>
-                <a:latin typeface="Arial" panose="020B0604020202020204" pitchFamily="34" charset="0"/>
-                <a:cs typeface="Arial" panose="020B0604020202020204" pitchFamily="34" charset="0"/>
+                <a:latin typeface="Aptos"/>
+                <a:cs typeface="Aptos"/>
               </a:rPr>
               <a:t>Synechron</a:t>
             </a:r>
@@ -1915,8 +1915,8 @@
                 <a:solidFill>
                   <a:srgbClr val="FFFFFF"/>
                 </a:solidFill>
-                <a:latin typeface="Arial" panose="020B0604020202020204" pitchFamily="34" charset="0"/>
-                <a:cs typeface="Arial" panose="020B0604020202020204" pitchFamily="34" charset="0"/>
+                <a:latin typeface="Aptos"/>
+                <a:cs typeface="Aptos"/>
               </a:rPr>
               <a:t>. All rights reserved. </a:t>
             </a:r>
@@ -1925,8 +1925,8 @@
                 <a:solidFill>
                   <a:srgbClr val="FFFFFF"/>
                 </a:solidFill>
-                <a:latin typeface="Arial" panose="020B0604020202020204" pitchFamily="34" charset="0"/>
-                <a:cs typeface="Arial" panose="020B0604020202020204" pitchFamily="34" charset="0"/>
+                <a:latin typeface="Aptos"/>
+                <a:cs typeface="Aptos"/>
               </a:rPr>
             </a:br>
             <a:r>
@@ -1934,9 +1934,9 @@
                 <a:solidFill>
                   <a:srgbClr val="FFFFFF"/>
                 </a:solidFill>
-                <a:latin typeface="Arial" panose="020B0604020202020204" pitchFamily="34" charset="0"/>
+                <a:latin typeface="Aptos"/>
                 <a:ea typeface="Carnas Light"/>
-                <a:cs typeface="Arial" panose="020B0604020202020204" pitchFamily="34" charset="0"/>
+                <a:cs typeface="Aptos"/>
                 <a:sym typeface="Carnas Light"/>
               </a:rPr>
               <a:t>No part of this presentation, concepts or designs may be used without permission.</a:t>
@@ -2163,8 +2163,8 @@
                 <a:solidFill>
                   <a:srgbClr val="FFFFFF"/>
                 </a:solidFill>
-                <a:latin typeface="Arial" panose="020B0604020202020204" pitchFamily="34" charset="0"/>
-                <a:cs typeface="Arial" panose="020B0604020202020204" pitchFamily="34" charset="0"/>
+                <a:latin typeface="Aptos"/>
+                <a:cs typeface="Aptos"/>
               </a:rPr>
               <a:t>© Copyright 202</a:t>
             </a:r>
@@ -2173,8 +2173,8 @@
                 <a:solidFill>
                   <a:srgbClr val="FFFFFF"/>
                 </a:solidFill>
-                <a:latin typeface="Arial" panose="020B0604020202020204" pitchFamily="34" charset="0"/>
-                <a:cs typeface="Arial" panose="020B0604020202020204" pitchFamily="34" charset="0"/>
+                <a:latin typeface="Aptos"/>
+                <a:cs typeface="Aptos"/>
               </a:rPr>
               <a:t>6</a:t>
             </a:r>
@@ -2183,8 +2183,8 @@
                 <a:solidFill>
                   <a:srgbClr val="FFFFFF"/>
                 </a:solidFill>
-                <a:latin typeface="Arial" panose="020B0604020202020204" pitchFamily="34" charset="0"/>
-                <a:cs typeface="Arial" panose="020B0604020202020204" pitchFamily="34" charset="0"/>
+                <a:latin typeface="Aptos"/>
+                <a:cs typeface="Aptos"/>
               </a:rPr>
               <a:t>. </a:t>
             </a:r>
@@ -2193,8 +2193,8 @@
                 <a:solidFill>
                   <a:srgbClr val="FFFFFF"/>
                 </a:solidFill>
-                <a:latin typeface="Arial" panose="020B0604020202020204" pitchFamily="34" charset="0"/>
-                <a:cs typeface="Arial" panose="020B0604020202020204" pitchFamily="34" charset="0"/>
+                <a:latin typeface="Aptos"/>
+                <a:cs typeface="Aptos"/>
               </a:rPr>
               <a:t>Synechron</a:t>
             </a:r>
@@ -2203,8 +2203,8 @@
                 <a:solidFill>
                   <a:srgbClr val="FFFFFF"/>
                 </a:solidFill>
-                <a:latin typeface="Arial" panose="020B0604020202020204" pitchFamily="34" charset="0"/>
-                <a:cs typeface="Arial" panose="020B0604020202020204" pitchFamily="34" charset="0"/>
+                <a:latin typeface="Aptos"/>
+                <a:cs typeface="Aptos"/>
               </a:rPr>
               <a:t>. All rights reserved. </a:t>
             </a:r>
@@ -2213,8 +2213,8 @@
                 <a:solidFill>
                   <a:srgbClr val="FFFFFF"/>
                 </a:solidFill>
-                <a:latin typeface="Arial" panose="020B0604020202020204" pitchFamily="34" charset="0"/>
-                <a:cs typeface="Arial" panose="020B0604020202020204" pitchFamily="34" charset="0"/>
+                <a:latin typeface="Aptos"/>
+                <a:cs typeface="Aptos"/>
               </a:rPr>
             </a:br>
             <a:r>
@@ -2222,9 +2222,9 @@
                 <a:solidFill>
                   <a:srgbClr val="FFFFFF"/>
                 </a:solidFill>
-                <a:latin typeface="Arial" panose="020B0604020202020204" pitchFamily="34" charset="0"/>
+                <a:latin typeface="Aptos"/>
                 <a:ea typeface="Carnas Light"/>
-                <a:cs typeface="Arial" panose="020B0604020202020204" pitchFamily="34" charset="0"/>
+                <a:cs typeface="Aptos"/>
                 <a:sym typeface="Carnas Light"/>
               </a:rPr>
               <a:t>No part of this presentation, concepts or designs may be used without permission.</a:t>
@@ -2473,7 +2473,7 @@
         <a:spcBef>
           <a:spcPts val="1000"/>
         </a:spcBef>
-        <a:buFont typeface="Arial" panose="020B0604020202020204" pitchFamily="34" charset="0"/>
+        <a:buFont typeface="Aptos"/>
         <a:buChar char="•"/>
         <a:defRPr lang="en-GB" sz="1400" kern="1200" smtClean="0">
           <a:solidFill>
@@ -2491,7 +2491,7 @@
         <a:spcBef>
           <a:spcPts val="500"/>
         </a:spcBef>
-        <a:buFont typeface="Arial" panose="020B0604020202020204" pitchFamily="34" charset="0"/>
+        <a:buFont typeface="Aptos"/>
         <a:buChar char="•"/>
         <a:defRPr lang="en-GB" sz="1400" kern="1200" smtClean="0">
           <a:solidFill>
@@ -2509,7 +2509,7 @@
         <a:spcBef>
           <a:spcPts val="500"/>
         </a:spcBef>
-        <a:buFont typeface="Arial" panose="020B0604020202020204" pitchFamily="34" charset="0"/>
+        <a:buFont typeface="Aptos"/>
         <a:buChar char="•"/>
         <a:defRPr lang="en-GB" sz="1400" kern="1200" smtClean="0">
           <a:solidFill>
@@ -2527,7 +2527,7 @@
         <a:spcBef>
           <a:spcPts val="500"/>
         </a:spcBef>
-        <a:buFont typeface="Arial" panose="020B0604020202020204" pitchFamily="34" charset="0"/>
+        <a:buFont typeface="Aptos"/>
         <a:buChar char="•"/>
         <a:defRPr lang="en-GB" sz="1400" kern="1200" smtClean="0">
           <a:solidFill>
@@ -2545,7 +2545,7 @@
         <a:spcBef>
           <a:spcPts val="500"/>
         </a:spcBef>
-        <a:buFont typeface="Arial" panose="020B0604020202020204" pitchFamily="34" charset="0"/>
+        <a:buFont typeface="Aptos"/>
         <a:buChar char="•"/>
         <a:defRPr lang="en-GB" sz="1400" kern="1200" smtClean="0">
           <a:solidFill>
@@ -2563,7 +2563,7 @@
         <a:spcBef>
           <a:spcPts val="500"/>
         </a:spcBef>
-        <a:buFont typeface="Arial" panose="020B0604020202020204" pitchFamily="34" charset="0"/>
+        <a:buFont typeface="Aptos"/>
         <a:buChar char="•"/>
         <a:defRPr sz="1800" kern="1200">
           <a:solidFill>
@@ -2581,7 +2581,7 @@
         <a:spcBef>
           <a:spcPts val="500"/>
         </a:spcBef>
-        <a:buFont typeface="Arial" panose="020B0604020202020204" pitchFamily="34" charset="0"/>
+        <a:buFont typeface="Aptos"/>
         <a:buChar char="•"/>
         <a:defRPr sz="1800" kern="1200">
           <a:solidFill>
@@ -2599,7 +2599,7 @@
         <a:spcBef>
           <a:spcPts val="500"/>
         </a:spcBef>
-        <a:buFont typeface="Arial" panose="020B0604020202020204" pitchFamily="34" charset="0"/>
+        <a:buFont typeface="Aptos"/>
         <a:buChar char="•"/>
         <a:defRPr sz="1800" kern="1200">
           <a:solidFill>
@@ -2617,7 +2617,7 @@
         <a:spcBef>
           <a:spcPts val="500"/>
         </a:spcBef>
-        <a:buFont typeface="Arial" panose="020B0604020202020204" pitchFamily="34" charset="0"/>
+        <a:buFont typeface="Aptos"/>
         <a:buChar char="•"/>
         <a:defRPr sz="1800" kern="1200">
           <a:solidFill>

</xml_diff>